<commit_message>
Finalize speech emotion recognition project report and presentation
</commit_message>
<xml_diff>
--- a/Speech Emotion Recognition/Speech_Emotion_Recognition_Presentation.pptx
+++ b/Speech Emotion Recognition/Speech_Emotion_Recognition_Presentation.pptx
@@ -5111,7 +5111,7 @@
                 </a:solidFill>
                 <a:latin typeface="Calibri"/>
               </a:rPr>
-              <a:t>Presented by Ronia Rosario K</a:t>
+              <a:t>Presented by Ronia Rosario K.</a:t>
             </a:r>
           </a:p>
           <a:p>
@@ -6069,7 +6069,7 @@
                 </a:solidFill>
                 <a:latin typeface="Calibri"/>
               </a:rPr>
-              <a:t>Experiments 1-3 compared with test scores visible: mildly optimistic</a:t>
+              <a:t>Test results were examined during comparisons of Experiments 1-3: test performance may be optimistic</a:t>
             </a:r>
           </a:p>
           <a:p>

</xml_diff>